<commit_message>
feat(templates): expand clean-room image role library
Add seven original calibration photographs, diversify image-led reference decks, and refresh native render evidence.
</commit_message>
<xml_diff>
--- a/skills/presentation-template-library/skills/artifact-template-apricot-dossier/assets/reference.pptx
+++ b/skills/presentation-template-library/skills/artifact-template-apricot-dossier/assets/reference.pptx
@@ -1085,7 +1085,7 @@
           <p:nvPr/>
         </p:nvPicPr>
         <p:blipFill>
-          <a:blip xmlns:r="http://schemas.openxmlformats.org/officeDocument/2006/relationships" xmlns:a="http://schemas.openxmlformats.org/drawingml/2006/main" r:embed="rIdOfficeKitImage34485ca5b8a9e954_1"/>
+          <a:blip xmlns:r="http://schemas.openxmlformats.org/officeDocument/2006/relationships" xmlns:a="http://schemas.openxmlformats.org/drawingml/2006/main" r:embed="rIdOfficeKitImageff039bf2f181c5d1_1"/>
           <a:srcRect xmlns:a="http://schemas.openxmlformats.org/drawingml/2006/main" l="0" t="47258" r="0" b="47258"/>
           <a:stretch xmlns:a="http://schemas.openxmlformats.org/drawingml/2006/main">
             <a:fillRect/>
@@ -2240,7 +2240,7 @@
           <p:nvPr/>
         </p:nvPicPr>
         <p:blipFill>
-          <a:blip xmlns:r="http://schemas.openxmlformats.org/officeDocument/2006/relationships" xmlns:a="http://schemas.openxmlformats.org/drawingml/2006/main" r:embed="rIdOfficeKitImagea5c00489db854fa2_1"/>
+          <a:blip xmlns:r="http://schemas.openxmlformats.org/officeDocument/2006/relationships" xmlns:a="http://schemas.openxmlformats.org/drawingml/2006/main" r:embed="rIdOfficeKitImage34485ca5b8a9e954_1"/>
           <a:srcRect xmlns:a="http://schemas.openxmlformats.org/drawingml/2006/main" l="0" t="47258" r="0" b="47258"/>
           <a:stretch xmlns:a="http://schemas.openxmlformats.org/drawingml/2006/main">
             <a:fillRect/>
@@ -2453,7 +2453,7 @@
         </p:xfrm>
         <a:graphic xmlns:a="http://schemas.openxmlformats.org/drawingml/2006/main">
           <a:graphicData uri="http://schemas.openxmlformats.org/drawingml/2006/chart">
-            <c:chart xmlns:r="http://schemas.openxmlformats.org/officeDocument/2006/relationships" xmlns:c="http://schemas.openxmlformats.org/drawingml/2006/chart" r:id="R3307f25c7c4d4970"/>
+            <c:chart xmlns:r="http://schemas.openxmlformats.org/officeDocument/2006/relationships" xmlns:c="http://schemas.openxmlformats.org/drawingml/2006/chart" r:id="Ra953169a114f438e"/>
           </a:graphicData>
         </a:graphic>
       </p:graphicFrame>
@@ -2471,7 +2471,7 @@
         </p:xfrm>
         <a:graphic xmlns:a="http://schemas.openxmlformats.org/drawingml/2006/main">
           <a:graphicData uri="http://schemas.openxmlformats.org/drawingml/2006/chart">
-            <c:chart xmlns:r="http://schemas.openxmlformats.org/officeDocument/2006/relationships" xmlns:c="http://schemas.openxmlformats.org/drawingml/2006/chart" r:id="R01649de8d8d440d9"/>
+            <c:chart xmlns:r="http://schemas.openxmlformats.org/officeDocument/2006/relationships" xmlns:c="http://schemas.openxmlformats.org/drawingml/2006/chart" r:id="Rc6b87e3b21dc4fe6"/>
           </a:graphicData>
         </a:graphic>
       </p:graphicFrame>
@@ -2842,8 +2842,8 @@
           <p:nvPr/>
         </p:nvPicPr>
         <p:blipFill>
-          <a:blip xmlns:r="http://schemas.openxmlformats.org/officeDocument/2006/relationships" xmlns:a="http://schemas.openxmlformats.org/drawingml/2006/main" r:embed="rIdOfficeKitImage7acdacea277813e8_1"/>
-          <a:srcRect xmlns:a="http://schemas.openxmlformats.org/drawingml/2006/main" l="0" t="47256" r="0" b="47256"/>
+          <a:blip xmlns:r="http://schemas.openxmlformats.org/officeDocument/2006/relationships" xmlns:a="http://schemas.openxmlformats.org/drawingml/2006/main" r:embed="rIdOfficeKitImagea5c00489db854fa2_1"/>
+          <a:srcRect xmlns:a="http://schemas.openxmlformats.org/drawingml/2006/main" l="0" t="47258" r="0" b="47258"/>
           <a:stretch xmlns:a="http://schemas.openxmlformats.org/drawingml/2006/main">
             <a:fillRect/>
           </a:stretch>
@@ -3712,7 +3712,7 @@
     <p:bg>
       <p:bgPr>
         <a:blipFill xmlns:a="http://schemas.openxmlformats.org/drawingml/2006/main">
-          <a:blip xmlns:r="http://schemas.openxmlformats.org/officeDocument/2006/relationships" r:embed="rIdOfficeKitImage06e55191024fa458_1"/>
+          <a:blip xmlns:r="http://schemas.openxmlformats.org/officeDocument/2006/relationships" r:embed="rIdOfficeKitImagee56ecbe4d29b219f_1"/>
           <a:stretch>
             <a:fillRect/>
           </a:stretch>
@@ -4139,7 +4139,7 @@
           <p:nvPr/>
         </p:nvPicPr>
         <p:blipFill>
-          <a:blip xmlns:r="http://schemas.openxmlformats.org/officeDocument/2006/relationships" xmlns:a="http://schemas.openxmlformats.org/drawingml/2006/main" r:embed="rIdOfficeKitImage89634c5b24a89a02_1"/>
+          <a:blip xmlns:r="http://schemas.openxmlformats.org/officeDocument/2006/relationships" xmlns:a="http://schemas.openxmlformats.org/drawingml/2006/main" r:embed="rIdOfficeKitImage7acdacea277813e8_1"/>
           <a:srcRect xmlns:a="http://schemas.openxmlformats.org/drawingml/2006/main" l="0" t="47256" r="0" b="47256"/>
           <a:stretch xmlns:a="http://schemas.openxmlformats.org/drawingml/2006/main">
             <a:fillRect/>

</xml_diff>